<commit_message>
Pitch deck: add the group-substitution feature
Slide 1's product statement now reads "reviews, approves, and edits:
one click substitutes a recipe for a whole group, safety-checked per
person — Agents propose. She decides. Nothing unsafe ships." Slide 3's
demo checklist gains the group-substitution beat (one recipe swapped
for ~100 clients at once, safety-checked per person).

Co-Authored-By: Claude Fable 5 <noreply@anthropic.com>
</commit_message>
<xml_diff>
--- a/pitch/RxKitchen-pitch.pptx
+++ b/pitch/RxKitchen-pitch.pptx
@@ -3378,7 +3378,7 @@
                   <a:srgbClr val="62625B"/>
                 </a:solidFill>
               </a:rPr>
-              <a:t>a multi-agent AI drafts the entire week — menus, batches, grocery kits — and the Chief Nutrition Officer reviews and approves. </a:t>
+              <a:t>a multi-agent AI drafts the entire week — menus, batches, grocery kits — and the Chief Nutrition Officer reviews, approves, and edits: one click substitutes a recipe for a whole group, safety-checked per person. </a:t>
             </a:r>
             <a:r>
               <a:rPr sz="1300" b="1">
@@ -3386,7 +3386,7 @@
                   <a:srgbClr val="211922"/>
                 </a:solidFill>
               </a:rPr>
-              <a:t>Agents propose. She approves. Nothing unsafe ships.</a:t>
+              <a:t>Agents propose. She decides. Nothing unsafe ships.</a:t>
             </a:r>
           </a:p>
         </p:txBody>
@@ -6080,6 +6080,36 @@
                 </a:solidFill>
               </a:rPr>
               <a:t>• “Why this meal?” — every check in plain words.</a:t>
+            </a:r>
+          </a:p>
+          <a:p>
+            <a:pPr algn="l">
+              <a:spcAft>
+                <a:spcPts val="700"/>
+              </a:spcAft>
+            </a:pPr>
+            <a:r>
+              <a:rPr sz="1100" b="0">
+                <a:solidFill>
+                  <a:srgbClr val="103C25"/>
+                </a:solidFill>
+              </a:rPr>
+              <a:t>• Group substitution → one recipe swapped for ~100</a:t>
+            </a:r>
+          </a:p>
+          <a:p>
+            <a:pPr algn="l">
+              <a:spcAft>
+                <a:spcPts val="700"/>
+              </a:spcAft>
+            </a:pPr>
+            <a:r>
+              <a:rPr sz="1100" b="0">
+                <a:solidFill>
+                  <a:srgbClr val="103C25"/>
+                </a:solidFill>
+              </a:rPr>
+              <a:t>   clients at once, safety-checked per person.</a:t>
             </a:r>
           </a:p>
           <a:p>

</xml_diff>

<commit_message>
Presentation: uncropped visit photos + problem-definition slide
- Photo slots switch from object-cover to object-contain (letterboxed,
  never cropped) with a capped row height — Katie's full LinkedIn
  message and the visit photos now show whole
- New slide 2 in both /presentation and the pptx (decks are now 4
  slides): "We're solving it for Project Open Hand — for nutritionists
  like Katie". Left: the problem, precisely (POH's reconciliation
  burden, clinical stakes, 150×7×5 scale math). Right: the persona card
  — Katie Jackson, CNO of Project Open Hand, interviewed on-site July
  16 — her accountabilities, non-technical needs, and definition of
  success, closing with "solve deeply for POH first, same shape fits
  every MTM org"
- Visit photos committed under public/pitch/

Verified all four slides in headless Chromium, zero console errors;
tsc + lint + build pass; pptx regenerated (4 slides, renumbered).

Co-Authored-By: Claude Fable 5 <noreply@anthropic.com>
</commit_message>
<xml_diff>
--- a/pitch/RxKitchen-pitch.pptx
+++ b/pitch/RxKitchen-pitch.pptx
@@ -8,6 +8,7 @@
     <p:sldId id="256" r:id="rId7"/>
     <p:sldId id="257" r:id="rId8"/>
     <p:sldId id="258" r:id="rId9"/>
+    <p:sldId id="259" r:id="rId10"/>
   </p:sldIdLst>
   <p:sldSz cx="12191695" cy="6858000" type="screen4x3"/>
   <p:notesSz cx="6858000" cy="9144000"/>
@@ -3837,7 +3838,7 @@
                   <a:srgbClr val="62625B"/>
                 </a:solidFill>
               </a:rPr>
-              <a:t>1 / 3</a:t>
+              <a:t>1 / 4</a:t>
             </a:r>
           </a:p>
         </p:txBody>
@@ -3965,7 +3966,7 @@
                   <a:srgbClr val="62625B"/>
                 </a:solidFill>
               </a:rPr>
-              <a:t>   · field research</a:t>
+              <a:t>   · problem definition</a:t>
             </a:r>
           </a:p>
         </p:txBody>
@@ -4003,7 +4004,7 @@
                   <a:srgbClr val="E60023"/>
                 </a:solidFill>
               </a:rPr>
-              <a:t>WE WENT TO THE SOURCE</a:t>
+              <a:t>WHO HAS THIS PROBLEM</a:t>
             </a:r>
           </a:p>
         </p:txBody>
@@ -4017,7 +4018,7 @@
         <p:spPr>
           <a:xfrm>
             <a:off x="548640" y="1298448"/>
-            <a:ext cx="10515600" cy="548640"/>
+            <a:ext cx="11155680" cy="914400"/>
           </a:xfrm>
           <a:prstGeom prst="rect">
             <a:avLst/>
@@ -4032,16 +4033,31 @@
           <a:p>
             <a:pPr algn="l">
               <a:spcAft>
-                <a:spcPts val="400"/>
-              </a:spcAft>
-            </a:pPr>
-            <a:r>
-              <a:rPr sz="3000" b="1">
+                <a:spcPts val="0"/>
+              </a:spcAft>
+            </a:pPr>
+            <a:r>
+              <a:rPr sz="2600" b="1">
                 <a:solidFill>
                   <a:srgbClr val="211922"/>
                 </a:solidFill>
               </a:rPr>
-              <a:t>Our visit to Project Open Hand</a:t>
+              <a:t>We're solving it for Project Open Hand —</a:t>
+            </a:r>
+          </a:p>
+          <a:p>
+            <a:pPr algn="l">
+              <a:spcAft>
+                <a:spcPts val="0"/>
+              </a:spcAft>
+            </a:pPr>
+            <a:r>
+              <a:rPr sz="2600" b="1">
+                <a:solidFill>
+                  <a:srgbClr val="211922"/>
+                </a:solidFill>
+              </a:rPr>
+              <a:t>for nutritionists like Katie</a:t>
             </a:r>
           </a:p>
         </p:txBody>
@@ -4054,492 +4070,8 @@
         </p:nvSpPr>
         <p:spPr>
           <a:xfrm>
-            <a:off x="548640" y="1993392"/>
-            <a:ext cx="2688336" cy="2761488"/>
-          </a:xfrm>
-          <a:prstGeom prst="roundRect">
-            <a:avLst>
-              <a:gd name="adj" fmla="val 10000"/>
-            </a:avLst>
-          </a:prstGeom>
-          <a:solidFill>
-            <a:srgbClr val="F0EFE9"/>
-          </a:solidFill>
-          <a:ln w="12700">
-            <a:solidFill>
-              <a:srgbClr val="DADAD3"/>
-            </a:solidFill>
-            <a:prstDash val="dash"/>
-          </a:ln>
-          <a:effectLst/>
-        </p:spPr>
-        <p:style>
-          <a:lnRef idx="1">
-            <a:schemeClr val="accent1"/>
-          </a:lnRef>
-          <a:fillRef idx="3">
-            <a:schemeClr val="accent1"/>
-          </a:fillRef>
-          <a:effectRef idx="2">
-            <a:schemeClr val="accent1"/>
-          </a:effectRef>
-          <a:fontRef idx="minor">
-            <a:schemeClr val="lt1"/>
-          </a:fontRef>
-        </p:style>
-        <p:txBody>
-          <a:bodyPr rtlCol="0" anchor="ctr" wrap="square" lIns="146304" rIns="146304" tIns="91440" bIns="91440"/>
-          <a:lstStyle/>
-          <a:p>
-            <a:pPr algn="ctr">
-              <a:spcAft>
-                <a:spcPts val="100"/>
-              </a:spcAft>
-            </a:pPr>
-            <a:r>
-              <a:rPr sz="1100" b="1">
-                <a:solidFill>
-                  <a:srgbClr val="62625B"/>
-                </a:solidFill>
-              </a:rPr>
-              <a:t>YOUR PHOTO HERE</a:t>
-            </a:r>
-          </a:p>
-          <a:p>
-            <a:pPr algn="ctr">
-              <a:spcAft>
-                <a:spcPts val="100"/>
-              </a:spcAft>
-            </a:pPr>
-            <a:r>
-              <a:rPr sz="600" b="0">
-                <a:solidFill>
-                  <a:srgbClr val="62625B"/>
-                </a:solidFill>
-              </a:rPr>
-              <a:t/>
-            </a:r>
-          </a:p>
-          <a:p>
-            <a:pPr algn="ctr">
-              <a:spcAft>
-                <a:spcPts val="100"/>
-              </a:spcAft>
-            </a:pPr>
-            <a:r>
-              <a:rPr sz="900" b="0">
-                <a:solidFill>
-                  <a:srgbClr val="62625B"/>
-                </a:solidFill>
-              </a:rPr>
-              <a:t>Insert → Picture →</a:t>
-            </a:r>
-          </a:p>
-          <a:p>
-            <a:pPr algn="ctr">
-              <a:spcAft>
-                <a:spcPts val="100"/>
-              </a:spcAft>
-            </a:pPr>
-            <a:r>
-              <a:rPr sz="900" b="0">
-                <a:solidFill>
-                  <a:srgbClr val="62625B"/>
-                </a:solidFill>
-              </a:rPr>
-              <a:t>This Device…</a:t>
-            </a:r>
-          </a:p>
-          <a:p>
-            <a:pPr algn="ctr">
-              <a:spcAft>
-                <a:spcPts val="100"/>
-              </a:spcAft>
-            </a:pPr>
-            <a:r>
-              <a:rPr sz="800" b="0">
-                <a:solidFill>
-                  <a:srgbClr val="62625B"/>
-                </a:solidFill>
-              </a:rPr>
-              <a:t>(visit photo 1, then delete this box)</a:t>
-            </a:r>
-          </a:p>
-        </p:txBody>
-      </p:sp>
-      <p:sp>
-        <p:nvSpPr>
-          <p:cNvPr id="7" name="Rounded Rectangle 6"/>
-          <p:cNvSpPr/>
-          <p:nvPr/>
-        </p:nvSpPr>
-        <p:spPr>
-          <a:xfrm>
-            <a:off x="3355848" y="1993392"/>
-            <a:ext cx="2688336" cy="2761488"/>
-          </a:xfrm>
-          <a:prstGeom prst="roundRect">
-            <a:avLst>
-              <a:gd name="adj" fmla="val 10000"/>
-            </a:avLst>
-          </a:prstGeom>
-          <a:solidFill>
-            <a:srgbClr val="F0EFE9"/>
-          </a:solidFill>
-          <a:ln w="12700">
-            <a:solidFill>
-              <a:srgbClr val="DADAD3"/>
-            </a:solidFill>
-            <a:prstDash val="dash"/>
-          </a:ln>
-          <a:effectLst/>
-        </p:spPr>
-        <p:style>
-          <a:lnRef idx="1">
-            <a:schemeClr val="accent1"/>
-          </a:lnRef>
-          <a:fillRef idx="3">
-            <a:schemeClr val="accent1"/>
-          </a:fillRef>
-          <a:effectRef idx="2">
-            <a:schemeClr val="accent1"/>
-          </a:effectRef>
-          <a:fontRef idx="minor">
-            <a:schemeClr val="lt1"/>
-          </a:fontRef>
-        </p:style>
-        <p:txBody>
-          <a:bodyPr rtlCol="0" anchor="ctr" wrap="square" lIns="146304" rIns="146304" tIns="91440" bIns="91440"/>
-          <a:lstStyle/>
-          <a:p>
-            <a:pPr algn="ctr">
-              <a:spcAft>
-                <a:spcPts val="100"/>
-              </a:spcAft>
-            </a:pPr>
-            <a:r>
-              <a:rPr sz="1100" b="1">
-                <a:solidFill>
-                  <a:srgbClr val="62625B"/>
-                </a:solidFill>
-              </a:rPr>
-              <a:t>YOUR PHOTO HERE</a:t>
-            </a:r>
-          </a:p>
-          <a:p>
-            <a:pPr algn="ctr">
-              <a:spcAft>
-                <a:spcPts val="100"/>
-              </a:spcAft>
-            </a:pPr>
-            <a:r>
-              <a:rPr sz="600" b="0">
-                <a:solidFill>
-                  <a:srgbClr val="62625B"/>
-                </a:solidFill>
-              </a:rPr>
-              <a:t/>
-            </a:r>
-          </a:p>
-          <a:p>
-            <a:pPr algn="ctr">
-              <a:spcAft>
-                <a:spcPts val="100"/>
-              </a:spcAft>
-            </a:pPr>
-            <a:r>
-              <a:rPr sz="900" b="0">
-                <a:solidFill>
-                  <a:srgbClr val="62625B"/>
-                </a:solidFill>
-              </a:rPr>
-              <a:t>Insert → Picture →</a:t>
-            </a:r>
-          </a:p>
-          <a:p>
-            <a:pPr algn="ctr">
-              <a:spcAft>
-                <a:spcPts val="100"/>
-              </a:spcAft>
-            </a:pPr>
-            <a:r>
-              <a:rPr sz="900" b="0">
-                <a:solidFill>
-                  <a:srgbClr val="62625B"/>
-                </a:solidFill>
-              </a:rPr>
-              <a:t>This Device…</a:t>
-            </a:r>
-          </a:p>
-          <a:p>
-            <a:pPr algn="ctr">
-              <a:spcAft>
-                <a:spcPts val="100"/>
-              </a:spcAft>
-            </a:pPr>
-            <a:r>
-              <a:rPr sz="800" b="0">
-                <a:solidFill>
-                  <a:srgbClr val="62625B"/>
-                </a:solidFill>
-              </a:rPr>
-              <a:t>(visit photo 2, then delete this box)</a:t>
-            </a:r>
-          </a:p>
-        </p:txBody>
-      </p:sp>
-      <p:sp>
-        <p:nvSpPr>
-          <p:cNvPr id="8" name="Rounded Rectangle 7"/>
-          <p:cNvSpPr/>
-          <p:nvPr/>
-        </p:nvSpPr>
-        <p:spPr>
-          <a:xfrm>
-            <a:off x="6163056" y="1993392"/>
-            <a:ext cx="2688336" cy="2761488"/>
-          </a:xfrm>
-          <a:prstGeom prst="roundRect">
-            <a:avLst>
-              <a:gd name="adj" fmla="val 10000"/>
-            </a:avLst>
-          </a:prstGeom>
-          <a:solidFill>
-            <a:srgbClr val="F0EFE9"/>
-          </a:solidFill>
-          <a:ln w="12700">
-            <a:solidFill>
-              <a:srgbClr val="DADAD3"/>
-            </a:solidFill>
-            <a:prstDash val="dash"/>
-          </a:ln>
-          <a:effectLst/>
-        </p:spPr>
-        <p:style>
-          <a:lnRef idx="1">
-            <a:schemeClr val="accent1"/>
-          </a:lnRef>
-          <a:fillRef idx="3">
-            <a:schemeClr val="accent1"/>
-          </a:fillRef>
-          <a:effectRef idx="2">
-            <a:schemeClr val="accent1"/>
-          </a:effectRef>
-          <a:fontRef idx="minor">
-            <a:schemeClr val="lt1"/>
-          </a:fontRef>
-        </p:style>
-        <p:txBody>
-          <a:bodyPr rtlCol="0" anchor="ctr" wrap="square" lIns="146304" rIns="146304" tIns="91440" bIns="91440"/>
-          <a:lstStyle/>
-          <a:p>
-            <a:pPr algn="ctr">
-              <a:spcAft>
-                <a:spcPts val="100"/>
-              </a:spcAft>
-            </a:pPr>
-            <a:r>
-              <a:rPr sz="1100" b="1">
-                <a:solidFill>
-                  <a:srgbClr val="62625B"/>
-                </a:solidFill>
-              </a:rPr>
-              <a:t>YOUR PHOTO HERE</a:t>
-            </a:r>
-          </a:p>
-          <a:p>
-            <a:pPr algn="ctr">
-              <a:spcAft>
-                <a:spcPts val="100"/>
-              </a:spcAft>
-            </a:pPr>
-            <a:r>
-              <a:rPr sz="600" b="0">
-                <a:solidFill>
-                  <a:srgbClr val="62625B"/>
-                </a:solidFill>
-              </a:rPr>
-              <a:t/>
-            </a:r>
-          </a:p>
-          <a:p>
-            <a:pPr algn="ctr">
-              <a:spcAft>
-                <a:spcPts val="100"/>
-              </a:spcAft>
-            </a:pPr>
-            <a:r>
-              <a:rPr sz="900" b="0">
-                <a:solidFill>
-                  <a:srgbClr val="62625B"/>
-                </a:solidFill>
-              </a:rPr>
-              <a:t>Insert → Picture →</a:t>
-            </a:r>
-          </a:p>
-          <a:p>
-            <a:pPr algn="ctr">
-              <a:spcAft>
-                <a:spcPts val="100"/>
-              </a:spcAft>
-            </a:pPr>
-            <a:r>
-              <a:rPr sz="900" b="0">
-                <a:solidFill>
-                  <a:srgbClr val="62625B"/>
-                </a:solidFill>
-              </a:rPr>
-              <a:t>This Device…</a:t>
-            </a:r>
-          </a:p>
-          <a:p>
-            <a:pPr algn="ctr">
-              <a:spcAft>
-                <a:spcPts val="100"/>
-              </a:spcAft>
-            </a:pPr>
-            <a:r>
-              <a:rPr sz="800" b="0">
-                <a:solidFill>
-                  <a:srgbClr val="62625B"/>
-                </a:solidFill>
-              </a:rPr>
-              <a:t>(visit photo 3, then delete this box)</a:t>
-            </a:r>
-          </a:p>
-        </p:txBody>
-      </p:sp>
-      <p:sp>
-        <p:nvSpPr>
-          <p:cNvPr id="9" name="Rounded Rectangle 8"/>
-          <p:cNvSpPr/>
-          <p:nvPr/>
-        </p:nvSpPr>
-        <p:spPr>
-          <a:xfrm>
-            <a:off x="8970264" y="1993392"/>
-            <a:ext cx="2688336" cy="2761488"/>
-          </a:xfrm>
-          <a:prstGeom prst="roundRect">
-            <a:avLst>
-              <a:gd name="adj" fmla="val 10000"/>
-            </a:avLst>
-          </a:prstGeom>
-          <a:solidFill>
-            <a:srgbClr val="F0EFE9"/>
-          </a:solidFill>
-          <a:ln w="12700">
-            <a:solidFill>
-              <a:srgbClr val="DADAD3"/>
-            </a:solidFill>
-            <a:prstDash val="dash"/>
-          </a:ln>
-          <a:effectLst/>
-        </p:spPr>
-        <p:style>
-          <a:lnRef idx="1">
-            <a:schemeClr val="accent1"/>
-          </a:lnRef>
-          <a:fillRef idx="3">
-            <a:schemeClr val="accent1"/>
-          </a:fillRef>
-          <a:effectRef idx="2">
-            <a:schemeClr val="accent1"/>
-          </a:effectRef>
-          <a:fontRef idx="minor">
-            <a:schemeClr val="lt1"/>
-          </a:fontRef>
-        </p:style>
-        <p:txBody>
-          <a:bodyPr rtlCol="0" anchor="ctr" wrap="square" lIns="146304" rIns="146304" tIns="91440" bIns="91440"/>
-          <a:lstStyle/>
-          <a:p>
-            <a:pPr algn="ctr">
-              <a:spcAft>
-                <a:spcPts val="100"/>
-              </a:spcAft>
-            </a:pPr>
-            <a:r>
-              <a:rPr sz="1100" b="1">
-                <a:solidFill>
-                  <a:srgbClr val="62625B"/>
-                </a:solidFill>
-              </a:rPr>
-              <a:t>YOUR PHOTO HERE</a:t>
-            </a:r>
-          </a:p>
-          <a:p>
-            <a:pPr algn="ctr">
-              <a:spcAft>
-                <a:spcPts val="100"/>
-              </a:spcAft>
-            </a:pPr>
-            <a:r>
-              <a:rPr sz="600" b="0">
-                <a:solidFill>
-                  <a:srgbClr val="62625B"/>
-                </a:solidFill>
-              </a:rPr>
-              <a:t/>
-            </a:r>
-          </a:p>
-          <a:p>
-            <a:pPr algn="ctr">
-              <a:spcAft>
-                <a:spcPts val="100"/>
-              </a:spcAft>
-            </a:pPr>
-            <a:r>
-              <a:rPr sz="900" b="0">
-                <a:solidFill>
-                  <a:srgbClr val="62625B"/>
-                </a:solidFill>
-              </a:rPr>
-              <a:t>Insert → Picture →</a:t>
-            </a:r>
-          </a:p>
-          <a:p>
-            <a:pPr algn="ctr">
-              <a:spcAft>
-                <a:spcPts val="100"/>
-              </a:spcAft>
-            </a:pPr>
-            <a:r>
-              <a:rPr sz="900" b="0">
-                <a:solidFill>
-                  <a:srgbClr val="62625B"/>
-                </a:solidFill>
-              </a:rPr>
-              <a:t>This Device…</a:t>
-            </a:r>
-          </a:p>
-          <a:p>
-            <a:pPr algn="ctr">
-              <a:spcAft>
-                <a:spcPts val="100"/>
-              </a:spcAft>
-            </a:pPr>
-            <a:r>
-              <a:rPr sz="800" b="0">
-                <a:solidFill>
-                  <a:srgbClr val="62625B"/>
-                </a:solidFill>
-              </a:rPr>
-              <a:t>(visit photo 4, then delete this box)</a:t>
-            </a:r>
-          </a:p>
-        </p:txBody>
-      </p:sp>
-      <p:sp>
-        <p:nvSpPr>
-          <p:cNvPr id="10" name="Rounded Rectangle 9"/>
-          <p:cNvSpPr/>
-          <p:nvPr/>
-        </p:nvSpPr>
-        <p:spPr>
-          <a:xfrm>
-            <a:off x="548640" y="4956048"/>
-            <a:ext cx="3657600" cy="1298448"/>
+            <a:off x="548640" y="2514600"/>
+            <a:ext cx="5715000" cy="3566160"/>
           </a:xfrm>
           <a:prstGeom prst="roundRect">
             <a:avLst>
@@ -4576,60 +4108,154 @@
           <a:p>
             <a:pPr algn="l">
               <a:spcAft>
-                <a:spcPts val="300"/>
-              </a:spcAft>
-            </a:pPr>
-            <a:r>
-              <a:rPr sz="1200" b="1">
+                <a:spcPts val="700"/>
+              </a:spcAft>
+            </a:pPr>
+            <a:r>
+              <a:rPr sz="1400" b="1">
                 <a:solidFill>
                   <a:srgbClr val="211922"/>
                 </a:solidFill>
               </a:rPr>
-              <a:t>Kitchens cook menus, not plates.</a:t>
+              <a:t>The problem, precisely</a:t>
             </a:r>
           </a:p>
           <a:p>
             <a:pPr algn="l">
               <a:spcAft>
-                <a:spcPts val="300"/>
-              </a:spcAft>
-            </a:pPr>
-            <a:r>
-              <a:rPr sz="1000" b="0">
+                <a:spcPts val="700"/>
+              </a:spcAft>
+            </a:pPr>
+            <a:r>
+              <a:rPr sz="1100" b="0">
                 <a:solidFill>
                   <a:srgbClr val="62625B"/>
                 </a:solidFill>
               </a:rPr>
-              <a:t>Bulk batches of a few recipes a day — never 150 bespoke meals.</a:t>
+              <a:t>• </a:t>
+            </a:r>
+            <a:r>
+              <a:rPr sz="1100" b="1">
+                <a:solidFill>
+                  <a:srgbClr val="211922"/>
+                </a:solidFill>
+              </a:rPr>
+              <a:t>Project Open Hand</a:t>
+            </a:r>
+            <a:r>
+              <a:rPr sz="1100" b="0">
+                <a:solidFill>
+                  <a:srgbClr val="62625B"/>
+                </a:solidFill>
+              </a:rPr>
+              <a:t> (San Francisco) delivers medically tailored meals to clients discharged with diabetes, cardiovascular and renal conditions, and allergies.</a:t>
             </a:r>
           </a:p>
           <a:p>
             <a:pPr algn="l">
               <a:spcAft>
-                <a:spcPts val="300"/>
-              </a:spcAft>
-            </a:pPr>
-            <a:r>
-              <a:rPr sz="900" b="1">
-                <a:solidFill>
-                  <a:srgbClr val="103C25"/>
-                </a:solidFill>
-              </a:rPr>
-              <a:t>→ 3–5 recipes/day menu planner</a:t>
-            </a:r>
-          </a:p>
-        </p:txBody>
-      </p:sp>
-      <p:sp>
-        <p:nvSpPr>
-          <p:cNvPr id="11" name="Rounded Rectangle 10"/>
+                <a:spcPts val="700"/>
+              </a:spcAft>
+            </a:pPr>
+            <a:r>
+              <a:rPr sz="1100" b="0">
+                <a:solidFill>
+                  <a:srgbClr val="62625B"/>
+                </a:solidFill>
+              </a:rPr>
+              <a:t>• Every referral must be reconciled against </a:t>
+            </a:r>
+            <a:r>
+              <a:rPr sz="1100" b="1">
+                <a:solidFill>
+                  <a:srgbClr val="211922"/>
+                </a:solidFill>
+              </a:rPr>
+              <a:t>diet prescriptions, today's stock, donated ingredients, and kitchen capacity</a:t>
+            </a:r>
+            <a:r>
+              <a:rPr sz="1100" b="0">
+                <a:solidFill>
+                  <a:srgbClr val="62625B"/>
+                </a:solidFill>
+              </a:rPr>
+              <a:t> — today that happens by hand, in spreadsheets, for hours per referral.</a:t>
+            </a:r>
+          </a:p>
+          <a:p>
+            <a:pPr algn="l">
+              <a:spcAft>
+                <a:spcPts val="700"/>
+              </a:spcAft>
+            </a:pPr>
+            <a:r>
+              <a:rPr sz="1100" b="0">
+                <a:solidFill>
+                  <a:srgbClr val="62625B"/>
+                </a:solidFill>
+              </a:rPr>
+              <a:t>• A missed allergen or sodium ceiling is a </a:t>
+            </a:r>
+            <a:r>
+              <a:rPr sz="1100" b="1">
+                <a:solidFill>
+                  <a:srgbClr val="211922"/>
+                </a:solidFill>
+              </a:rPr>
+              <a:t>clinical incident</a:t>
+            </a:r>
+            <a:r>
+              <a:rPr sz="1100" b="0">
+                <a:solidFill>
+                  <a:srgbClr val="62625B"/>
+                </a:solidFill>
+              </a:rPr>
+              <a:t>, not a typo — so everything bottlenecks on the nutrition team.</a:t>
+            </a:r>
+          </a:p>
+          <a:p>
+            <a:pPr algn="l">
+              <a:spcAft>
+                <a:spcPts val="700"/>
+              </a:spcAft>
+            </a:pPr>
+            <a:r>
+              <a:rPr sz="1100" b="0">
+                <a:solidFill>
+                  <a:srgbClr val="62625B"/>
+                </a:solidFill>
+              </a:rPr>
+              <a:t>• Scale breaks the manual process: </a:t>
+            </a:r>
+            <a:r>
+              <a:rPr sz="1100" b="1">
+                <a:solidFill>
+                  <a:srgbClr val="211922"/>
+                </a:solidFill>
+              </a:rPr>
+              <a:t>150 clients × 7 meals × 5 hard constraints</a:t>
+            </a:r>
+            <a:r>
+              <a:rPr sz="1100" b="0">
+                <a:solidFill>
+                  <a:srgbClr val="62625B"/>
+                </a:solidFill>
+              </a:rPr>
+              <a:t> is thousands of safety decisions every week.</a:t>
+            </a:r>
+          </a:p>
+        </p:txBody>
+      </p:sp>
+      <p:sp>
+        <p:nvSpPr>
+          <p:cNvPr id="7" name="Rounded Rectangle 6"/>
           <p:cNvSpPr/>
           <p:nvPr/>
         </p:nvSpPr>
         <p:spPr>
           <a:xfrm>
-            <a:off x="4334255" y="4956048"/>
-            <a:ext cx="3657600" cy="1298448"/>
+            <a:off x="6400800" y="2514600"/>
+            <a:ext cx="5257800" cy="3566160"/>
           </a:xfrm>
           <a:prstGeom prst="roundRect">
             <a:avLst>
@@ -4637,11 +4263,11 @@
             </a:avLst>
           </a:prstGeom>
           <a:solidFill>
-            <a:srgbClr val="FFFFFF"/>
+            <a:srgbClr val="C7F0DA"/>
           </a:solidFill>
           <a:ln w="12700">
             <a:solidFill>
-              <a:srgbClr val="DADAD3"/>
+              <a:srgbClr val="A8DCC0"/>
             </a:solidFill>
           </a:ln>
           <a:effectLst/>
@@ -4666,143 +4292,128 @@
           <a:p>
             <a:pPr algn="l">
               <a:spcAft>
-                <a:spcPts val="300"/>
+                <a:spcPts val="600"/>
+              </a:spcAft>
+            </a:pPr>
+            <a:r>
+              <a:rPr sz="1400" b="1">
+                <a:solidFill>
+                  <a:srgbClr val="103C25"/>
+                </a:solidFill>
+              </a:rPr>
+              <a:t>Who we're building for</a:t>
+            </a:r>
+          </a:p>
+          <a:p>
+            <a:pPr algn="l">
+              <a:spcAft>
+                <a:spcPts val="600"/>
               </a:spcAft>
             </a:pPr>
             <a:r>
               <a:rPr sz="1200" b="1">
                 <a:solidFill>
-                  <a:srgbClr val="211922"/>
-                </a:solidFill>
-              </a:rPr>
-              <a:t>Donations are a lottery.</a:t>
+                  <a:srgbClr val="103C25"/>
+                </a:solidFill>
+              </a:rPr>
+              <a:t>Katie Jackson · Chief Nutrition Officer, Project Open Hand</a:t>
             </a:r>
           </a:p>
           <a:p>
             <a:pPr algn="l">
               <a:spcAft>
-                <a:spcPts val="300"/>
+                <a:spcPts val="600"/>
               </a:spcAft>
             </a:pPr>
             <a:r>
               <a:rPr sz="1000" b="0">
                 <a:solidFill>
-                  <a:srgbClr val="62625B"/>
-                </a:solidFill>
-              </a:rPr>
-              <a:t>What arrives is unpredictable; using it well is the margin that funds meals.</a:t>
+                  <a:srgbClr val="103C25"/>
+                </a:solidFill>
+              </a:rPr>
+              <a:t>interviewed on-site · July 16, 2026</a:t>
             </a:r>
           </a:p>
           <a:p>
             <a:pPr algn="l">
               <a:spcAft>
-                <a:spcPts val="300"/>
-              </a:spcAft>
-            </a:pPr>
-            <a:r>
-              <a:rPr sz="900" b="1">
+                <a:spcPts val="600"/>
+              </a:spcAft>
+            </a:pPr>
+            <a:r>
+              <a:rPr sz="1100" b="0">
                 <a:solidFill>
                   <a:srgbClr val="103C25"/>
                 </a:solidFill>
               </a:rPr>
-              <a:t>→ triage gate + donation-to-recipe routing</a:t>
-            </a:r>
-          </a:p>
-        </p:txBody>
-      </p:sp>
-      <p:sp>
-        <p:nvSpPr>
-          <p:cNvPr id="12" name="Rounded Rectangle 11"/>
-          <p:cNvSpPr/>
-          <p:nvPr/>
-        </p:nvSpPr>
-        <p:spPr>
-          <a:xfrm>
-            <a:off x="8119871" y="4956048"/>
-            <a:ext cx="3657600" cy="1298448"/>
-          </a:xfrm>
-          <a:prstGeom prst="roundRect">
-            <a:avLst>
-              <a:gd name="adj" fmla="val 10000"/>
-            </a:avLst>
-          </a:prstGeom>
-          <a:solidFill>
-            <a:srgbClr val="FFFFFF"/>
-          </a:solidFill>
-          <a:ln w="12700">
-            <a:solidFill>
-              <a:srgbClr val="DADAD3"/>
-            </a:solidFill>
-          </a:ln>
-          <a:effectLst/>
-        </p:spPr>
-        <p:style>
-          <a:lnRef idx="1">
-            <a:schemeClr val="accent1"/>
-          </a:lnRef>
-          <a:fillRef idx="3">
-            <a:schemeClr val="accent1"/>
-          </a:fillRef>
-          <a:effectRef idx="2">
-            <a:schemeClr val="accent1"/>
-          </a:effectRef>
-          <a:fontRef idx="minor">
-            <a:schemeClr val="lt1"/>
-          </a:fontRef>
-        </p:style>
-        <p:txBody>
-          <a:bodyPr rtlCol="0" anchor="t" wrap="square" lIns="146304" rIns="146304" tIns="91440" bIns="91440"/>
-          <a:lstStyle/>
+              <a:t>• Clinically accountable — she signs off on every meal that ships.</a:t>
+            </a:r>
+          </a:p>
           <a:p>
             <a:pPr algn="l">
               <a:spcAft>
-                <a:spcPts val="300"/>
-              </a:spcAft>
-            </a:pPr>
-            <a:r>
-              <a:rPr sz="1200" b="1">
-                <a:solidFill>
-                  <a:srgbClr val="211922"/>
-                </a:solidFill>
-              </a:rPr>
-              <a:t>A human signs off on safety.</a:t>
+                <a:spcPts val="600"/>
+              </a:spcAft>
+            </a:pPr>
+            <a:r>
+              <a:rPr sz="1100" b="0">
+                <a:solidFill>
+                  <a:srgbClr val="103C25"/>
+                </a:solidFill>
+              </a:rPr>
+              <a:t>• Plans for the whole kitchen: weekly menus, batches, donations — not one plate at a time.</a:t>
             </a:r>
           </a:p>
           <a:p>
             <a:pPr algn="l">
               <a:spcAft>
-                <a:spcPts val="300"/>
+                <a:spcPts val="600"/>
+              </a:spcAft>
+            </a:pPr>
+            <a:r>
+              <a:rPr sz="1100" b="0">
+                <a:solidFill>
+                  <a:srgbClr val="103C25"/>
+                </a:solidFill>
+              </a:rPr>
+              <a:t>• Not technical — needs plain language and one-glance safety.</a:t>
+            </a:r>
+          </a:p>
+          <a:p>
+            <a:pPr algn="l">
+              <a:spcAft>
+                <a:spcPts val="600"/>
+              </a:spcAft>
+            </a:pPr>
+            <a:r>
+              <a:rPr sz="1100" b="1">
+                <a:solidFill>
+                  <a:srgbClr val="103C25"/>
+                </a:solidFill>
+              </a:rPr>
+              <a:t>• Success = nothing unsafe ships, nobody unfed, donations not wasted.</a:t>
+            </a:r>
+          </a:p>
+          <a:p>
+            <a:pPr algn="l">
+              <a:spcAft>
+                <a:spcPts val="600"/>
               </a:spcAft>
             </a:pPr>
             <a:r>
               <a:rPr sz="1000" b="0">
                 <a:solidFill>
-                  <a:srgbClr val="62625B"/>
-                </a:solidFill>
-              </a:rPr>
-              <a:t>The nutrition team is clinically accountable — automation can draft, not decide.</a:t>
-            </a:r>
-          </a:p>
-          <a:p>
-            <a:pPr algn="l">
-              <a:spcAft>
-                <a:spcPts val="300"/>
-              </a:spcAft>
-            </a:pPr>
-            <a:r>
-              <a:rPr sz="900" b="1">
-                <a:solidFill>
                   <a:srgbClr val="103C25"/>
                 </a:solidFill>
               </a:rPr>
-              <a:t>→ approve-to-send workflow, gated on 0 issues</a:t>
-            </a:r>
-          </a:p>
-        </p:txBody>
-      </p:sp>
-      <p:sp>
-        <p:nvSpPr>
-          <p:cNvPr id="13" name="TextBox 12"/>
+              <a:t>Solving it deeply for POH first — the same shape fits every MTM org.</a:t>
+            </a:r>
+          </a:p>
+        </p:txBody>
+      </p:sp>
+      <p:sp>
+        <p:nvSpPr>
+          <p:cNvPr id="8" name="TextBox 7"/>
           <p:cNvSpPr txBox="1"/>
           <p:nvPr/>
         </p:nvSpPr>
@@ -4833,14 +4444,14 @@
                   <a:srgbClr val="62625B"/>
                 </a:solidFill>
               </a:rPr>
-              <a:t>What we learned became the product's shape</a:t>
-            </a:r>
-          </a:p>
-        </p:txBody>
-      </p:sp>
-      <p:sp>
-        <p:nvSpPr>
-          <p:cNvPr id="14" name="TextBox 13"/>
+              <a:t>Built with and for the people doing the work today</a:t>
+            </a:r>
+          </a:p>
+        </p:txBody>
+      </p:sp>
+      <p:sp>
+        <p:nvSpPr>
+          <p:cNvPr id="9" name="TextBox 8"/>
           <p:cNvSpPr txBox="1"/>
           <p:nvPr/>
         </p:nvSpPr>
@@ -4871,7 +4482,7 @@
                   <a:srgbClr val="62625B"/>
                 </a:solidFill>
               </a:rPr>
-              <a:t>2 / 3</a:t>
+              <a:t>2 / 4</a:t>
             </a:r>
           </a:p>
         </p:txBody>
@@ -4999,7 +4610,7 @@
                   <a:srgbClr val="62625B"/>
                 </a:solidFill>
               </a:rPr>
-              <a:t>   · how it works</a:t>
+              <a:t>   · field research</a:t>
             </a:r>
           </a:p>
         </p:txBody>
@@ -5037,7 +4648,7 @@
                   <a:srgbClr val="E60023"/>
                 </a:solidFill>
               </a:rPr>
-              <a:t>REFERRAL TO DOORSTEP, IN MINUTES</a:t>
+              <a:t>WE WENT TO THE SOURCE</a:t>
             </a:r>
           </a:p>
         </p:txBody>
@@ -5051,7 +4662,7 @@
         <p:spPr>
           <a:xfrm>
             <a:off x="548640" y="1298448"/>
-            <a:ext cx="11155680" cy="502920"/>
+            <a:ext cx="10515600" cy="548640"/>
           </a:xfrm>
           <a:prstGeom prst="rect">
             <a:avLst/>
@@ -5070,12 +4681,12 @@
               </a:spcAft>
             </a:pPr>
             <a:r>
-              <a:rPr sz="2600" b="1">
+              <a:rPr sz="3000" b="1">
                 <a:solidFill>
                   <a:srgbClr val="211922"/>
                 </a:solidFill>
               </a:rPr>
-              <a:t>Specialist agents, one safety hierarchy, a human decision</a:t>
+              <a:t>Our visit to Project Open Hand</a:t>
             </a:r>
           </a:p>
         </p:txBody>
@@ -5088,8 +4699,492 @@
         </p:nvSpPr>
         <p:spPr>
           <a:xfrm>
-            <a:off x="502920" y="1938528"/>
-            <a:ext cx="1700784" cy="1225296"/>
+            <a:off x="548640" y="1993392"/>
+            <a:ext cx="2688336" cy="2761488"/>
+          </a:xfrm>
+          <a:prstGeom prst="roundRect">
+            <a:avLst>
+              <a:gd name="adj" fmla="val 10000"/>
+            </a:avLst>
+          </a:prstGeom>
+          <a:solidFill>
+            <a:srgbClr val="F0EFE9"/>
+          </a:solidFill>
+          <a:ln w="12700">
+            <a:solidFill>
+              <a:srgbClr val="DADAD3"/>
+            </a:solidFill>
+            <a:prstDash val="dash"/>
+          </a:ln>
+          <a:effectLst/>
+        </p:spPr>
+        <p:style>
+          <a:lnRef idx="1">
+            <a:schemeClr val="accent1"/>
+          </a:lnRef>
+          <a:fillRef idx="3">
+            <a:schemeClr val="accent1"/>
+          </a:fillRef>
+          <a:effectRef idx="2">
+            <a:schemeClr val="accent1"/>
+          </a:effectRef>
+          <a:fontRef idx="minor">
+            <a:schemeClr val="lt1"/>
+          </a:fontRef>
+        </p:style>
+        <p:txBody>
+          <a:bodyPr rtlCol="0" anchor="ctr" wrap="square" lIns="146304" rIns="146304" tIns="91440" bIns="91440"/>
+          <a:lstStyle/>
+          <a:p>
+            <a:pPr algn="ctr">
+              <a:spcAft>
+                <a:spcPts val="100"/>
+              </a:spcAft>
+            </a:pPr>
+            <a:r>
+              <a:rPr sz="1100" b="1">
+                <a:solidFill>
+                  <a:srgbClr val="62625B"/>
+                </a:solidFill>
+              </a:rPr>
+              <a:t>YOUR PHOTO HERE</a:t>
+            </a:r>
+          </a:p>
+          <a:p>
+            <a:pPr algn="ctr">
+              <a:spcAft>
+                <a:spcPts val="100"/>
+              </a:spcAft>
+            </a:pPr>
+            <a:r>
+              <a:rPr sz="600" b="0">
+                <a:solidFill>
+                  <a:srgbClr val="62625B"/>
+                </a:solidFill>
+              </a:rPr>
+              <a:t/>
+            </a:r>
+          </a:p>
+          <a:p>
+            <a:pPr algn="ctr">
+              <a:spcAft>
+                <a:spcPts val="100"/>
+              </a:spcAft>
+            </a:pPr>
+            <a:r>
+              <a:rPr sz="900" b="0">
+                <a:solidFill>
+                  <a:srgbClr val="62625B"/>
+                </a:solidFill>
+              </a:rPr>
+              <a:t>Insert → Picture →</a:t>
+            </a:r>
+          </a:p>
+          <a:p>
+            <a:pPr algn="ctr">
+              <a:spcAft>
+                <a:spcPts val="100"/>
+              </a:spcAft>
+            </a:pPr>
+            <a:r>
+              <a:rPr sz="900" b="0">
+                <a:solidFill>
+                  <a:srgbClr val="62625B"/>
+                </a:solidFill>
+              </a:rPr>
+              <a:t>This Device…</a:t>
+            </a:r>
+          </a:p>
+          <a:p>
+            <a:pPr algn="ctr">
+              <a:spcAft>
+                <a:spcPts val="100"/>
+              </a:spcAft>
+            </a:pPr>
+            <a:r>
+              <a:rPr sz="800" b="0">
+                <a:solidFill>
+                  <a:srgbClr val="62625B"/>
+                </a:solidFill>
+              </a:rPr>
+              <a:t>(visit photo 1, then delete this box)</a:t>
+            </a:r>
+          </a:p>
+        </p:txBody>
+      </p:sp>
+      <p:sp>
+        <p:nvSpPr>
+          <p:cNvPr id="7" name="Rounded Rectangle 6"/>
+          <p:cNvSpPr/>
+          <p:nvPr/>
+        </p:nvSpPr>
+        <p:spPr>
+          <a:xfrm>
+            <a:off x="3355848" y="1993392"/>
+            <a:ext cx="2688336" cy="2761488"/>
+          </a:xfrm>
+          <a:prstGeom prst="roundRect">
+            <a:avLst>
+              <a:gd name="adj" fmla="val 10000"/>
+            </a:avLst>
+          </a:prstGeom>
+          <a:solidFill>
+            <a:srgbClr val="F0EFE9"/>
+          </a:solidFill>
+          <a:ln w="12700">
+            <a:solidFill>
+              <a:srgbClr val="DADAD3"/>
+            </a:solidFill>
+            <a:prstDash val="dash"/>
+          </a:ln>
+          <a:effectLst/>
+        </p:spPr>
+        <p:style>
+          <a:lnRef idx="1">
+            <a:schemeClr val="accent1"/>
+          </a:lnRef>
+          <a:fillRef idx="3">
+            <a:schemeClr val="accent1"/>
+          </a:fillRef>
+          <a:effectRef idx="2">
+            <a:schemeClr val="accent1"/>
+          </a:effectRef>
+          <a:fontRef idx="minor">
+            <a:schemeClr val="lt1"/>
+          </a:fontRef>
+        </p:style>
+        <p:txBody>
+          <a:bodyPr rtlCol="0" anchor="ctr" wrap="square" lIns="146304" rIns="146304" tIns="91440" bIns="91440"/>
+          <a:lstStyle/>
+          <a:p>
+            <a:pPr algn="ctr">
+              <a:spcAft>
+                <a:spcPts val="100"/>
+              </a:spcAft>
+            </a:pPr>
+            <a:r>
+              <a:rPr sz="1100" b="1">
+                <a:solidFill>
+                  <a:srgbClr val="62625B"/>
+                </a:solidFill>
+              </a:rPr>
+              <a:t>YOUR PHOTO HERE</a:t>
+            </a:r>
+          </a:p>
+          <a:p>
+            <a:pPr algn="ctr">
+              <a:spcAft>
+                <a:spcPts val="100"/>
+              </a:spcAft>
+            </a:pPr>
+            <a:r>
+              <a:rPr sz="600" b="0">
+                <a:solidFill>
+                  <a:srgbClr val="62625B"/>
+                </a:solidFill>
+              </a:rPr>
+              <a:t/>
+            </a:r>
+          </a:p>
+          <a:p>
+            <a:pPr algn="ctr">
+              <a:spcAft>
+                <a:spcPts val="100"/>
+              </a:spcAft>
+            </a:pPr>
+            <a:r>
+              <a:rPr sz="900" b="0">
+                <a:solidFill>
+                  <a:srgbClr val="62625B"/>
+                </a:solidFill>
+              </a:rPr>
+              <a:t>Insert → Picture →</a:t>
+            </a:r>
+          </a:p>
+          <a:p>
+            <a:pPr algn="ctr">
+              <a:spcAft>
+                <a:spcPts val="100"/>
+              </a:spcAft>
+            </a:pPr>
+            <a:r>
+              <a:rPr sz="900" b="0">
+                <a:solidFill>
+                  <a:srgbClr val="62625B"/>
+                </a:solidFill>
+              </a:rPr>
+              <a:t>This Device…</a:t>
+            </a:r>
+          </a:p>
+          <a:p>
+            <a:pPr algn="ctr">
+              <a:spcAft>
+                <a:spcPts val="100"/>
+              </a:spcAft>
+            </a:pPr>
+            <a:r>
+              <a:rPr sz="800" b="0">
+                <a:solidFill>
+                  <a:srgbClr val="62625B"/>
+                </a:solidFill>
+              </a:rPr>
+              <a:t>(visit photo 2, then delete this box)</a:t>
+            </a:r>
+          </a:p>
+        </p:txBody>
+      </p:sp>
+      <p:sp>
+        <p:nvSpPr>
+          <p:cNvPr id="8" name="Rounded Rectangle 7"/>
+          <p:cNvSpPr/>
+          <p:nvPr/>
+        </p:nvSpPr>
+        <p:spPr>
+          <a:xfrm>
+            <a:off x="6163056" y="1993392"/>
+            <a:ext cx="2688336" cy="2761488"/>
+          </a:xfrm>
+          <a:prstGeom prst="roundRect">
+            <a:avLst>
+              <a:gd name="adj" fmla="val 10000"/>
+            </a:avLst>
+          </a:prstGeom>
+          <a:solidFill>
+            <a:srgbClr val="F0EFE9"/>
+          </a:solidFill>
+          <a:ln w="12700">
+            <a:solidFill>
+              <a:srgbClr val="DADAD3"/>
+            </a:solidFill>
+            <a:prstDash val="dash"/>
+          </a:ln>
+          <a:effectLst/>
+        </p:spPr>
+        <p:style>
+          <a:lnRef idx="1">
+            <a:schemeClr val="accent1"/>
+          </a:lnRef>
+          <a:fillRef idx="3">
+            <a:schemeClr val="accent1"/>
+          </a:fillRef>
+          <a:effectRef idx="2">
+            <a:schemeClr val="accent1"/>
+          </a:effectRef>
+          <a:fontRef idx="minor">
+            <a:schemeClr val="lt1"/>
+          </a:fontRef>
+        </p:style>
+        <p:txBody>
+          <a:bodyPr rtlCol="0" anchor="ctr" wrap="square" lIns="146304" rIns="146304" tIns="91440" bIns="91440"/>
+          <a:lstStyle/>
+          <a:p>
+            <a:pPr algn="ctr">
+              <a:spcAft>
+                <a:spcPts val="100"/>
+              </a:spcAft>
+            </a:pPr>
+            <a:r>
+              <a:rPr sz="1100" b="1">
+                <a:solidFill>
+                  <a:srgbClr val="62625B"/>
+                </a:solidFill>
+              </a:rPr>
+              <a:t>YOUR PHOTO HERE</a:t>
+            </a:r>
+          </a:p>
+          <a:p>
+            <a:pPr algn="ctr">
+              <a:spcAft>
+                <a:spcPts val="100"/>
+              </a:spcAft>
+            </a:pPr>
+            <a:r>
+              <a:rPr sz="600" b="0">
+                <a:solidFill>
+                  <a:srgbClr val="62625B"/>
+                </a:solidFill>
+              </a:rPr>
+              <a:t/>
+            </a:r>
+          </a:p>
+          <a:p>
+            <a:pPr algn="ctr">
+              <a:spcAft>
+                <a:spcPts val="100"/>
+              </a:spcAft>
+            </a:pPr>
+            <a:r>
+              <a:rPr sz="900" b="0">
+                <a:solidFill>
+                  <a:srgbClr val="62625B"/>
+                </a:solidFill>
+              </a:rPr>
+              <a:t>Insert → Picture →</a:t>
+            </a:r>
+          </a:p>
+          <a:p>
+            <a:pPr algn="ctr">
+              <a:spcAft>
+                <a:spcPts val="100"/>
+              </a:spcAft>
+            </a:pPr>
+            <a:r>
+              <a:rPr sz="900" b="0">
+                <a:solidFill>
+                  <a:srgbClr val="62625B"/>
+                </a:solidFill>
+              </a:rPr>
+              <a:t>This Device…</a:t>
+            </a:r>
+          </a:p>
+          <a:p>
+            <a:pPr algn="ctr">
+              <a:spcAft>
+                <a:spcPts val="100"/>
+              </a:spcAft>
+            </a:pPr>
+            <a:r>
+              <a:rPr sz="800" b="0">
+                <a:solidFill>
+                  <a:srgbClr val="62625B"/>
+                </a:solidFill>
+              </a:rPr>
+              <a:t>(visit photo 3, then delete this box)</a:t>
+            </a:r>
+          </a:p>
+        </p:txBody>
+      </p:sp>
+      <p:sp>
+        <p:nvSpPr>
+          <p:cNvPr id="9" name="Rounded Rectangle 8"/>
+          <p:cNvSpPr/>
+          <p:nvPr/>
+        </p:nvSpPr>
+        <p:spPr>
+          <a:xfrm>
+            <a:off x="8970264" y="1993392"/>
+            <a:ext cx="2688336" cy="2761488"/>
+          </a:xfrm>
+          <a:prstGeom prst="roundRect">
+            <a:avLst>
+              <a:gd name="adj" fmla="val 10000"/>
+            </a:avLst>
+          </a:prstGeom>
+          <a:solidFill>
+            <a:srgbClr val="F0EFE9"/>
+          </a:solidFill>
+          <a:ln w="12700">
+            <a:solidFill>
+              <a:srgbClr val="DADAD3"/>
+            </a:solidFill>
+            <a:prstDash val="dash"/>
+          </a:ln>
+          <a:effectLst/>
+        </p:spPr>
+        <p:style>
+          <a:lnRef idx="1">
+            <a:schemeClr val="accent1"/>
+          </a:lnRef>
+          <a:fillRef idx="3">
+            <a:schemeClr val="accent1"/>
+          </a:fillRef>
+          <a:effectRef idx="2">
+            <a:schemeClr val="accent1"/>
+          </a:effectRef>
+          <a:fontRef idx="minor">
+            <a:schemeClr val="lt1"/>
+          </a:fontRef>
+        </p:style>
+        <p:txBody>
+          <a:bodyPr rtlCol="0" anchor="ctr" wrap="square" lIns="146304" rIns="146304" tIns="91440" bIns="91440"/>
+          <a:lstStyle/>
+          <a:p>
+            <a:pPr algn="ctr">
+              <a:spcAft>
+                <a:spcPts val="100"/>
+              </a:spcAft>
+            </a:pPr>
+            <a:r>
+              <a:rPr sz="1100" b="1">
+                <a:solidFill>
+                  <a:srgbClr val="62625B"/>
+                </a:solidFill>
+              </a:rPr>
+              <a:t>YOUR PHOTO HERE</a:t>
+            </a:r>
+          </a:p>
+          <a:p>
+            <a:pPr algn="ctr">
+              <a:spcAft>
+                <a:spcPts val="100"/>
+              </a:spcAft>
+            </a:pPr>
+            <a:r>
+              <a:rPr sz="600" b="0">
+                <a:solidFill>
+                  <a:srgbClr val="62625B"/>
+                </a:solidFill>
+              </a:rPr>
+              <a:t/>
+            </a:r>
+          </a:p>
+          <a:p>
+            <a:pPr algn="ctr">
+              <a:spcAft>
+                <a:spcPts val="100"/>
+              </a:spcAft>
+            </a:pPr>
+            <a:r>
+              <a:rPr sz="900" b="0">
+                <a:solidFill>
+                  <a:srgbClr val="62625B"/>
+                </a:solidFill>
+              </a:rPr>
+              <a:t>Insert → Picture →</a:t>
+            </a:r>
+          </a:p>
+          <a:p>
+            <a:pPr algn="ctr">
+              <a:spcAft>
+                <a:spcPts val="100"/>
+              </a:spcAft>
+            </a:pPr>
+            <a:r>
+              <a:rPr sz="900" b="0">
+                <a:solidFill>
+                  <a:srgbClr val="62625B"/>
+                </a:solidFill>
+              </a:rPr>
+              <a:t>This Device…</a:t>
+            </a:r>
+          </a:p>
+          <a:p>
+            <a:pPr algn="ctr">
+              <a:spcAft>
+                <a:spcPts val="100"/>
+              </a:spcAft>
+            </a:pPr>
+            <a:r>
+              <a:rPr sz="800" b="0">
+                <a:solidFill>
+                  <a:srgbClr val="62625B"/>
+                </a:solidFill>
+              </a:rPr>
+              <a:t>(visit photo 4, then delete this box)</a:t>
+            </a:r>
+          </a:p>
+        </p:txBody>
+      </p:sp>
+      <p:sp>
+        <p:nvSpPr>
+          <p:cNvPr id="10" name="Rounded Rectangle 9"/>
+          <p:cNvSpPr/>
+          <p:nvPr/>
+        </p:nvSpPr>
+        <p:spPr>
+          <a:xfrm>
+            <a:off x="548640" y="4956048"/>
+            <a:ext cx="3657600" cy="1298448"/>
           </a:xfrm>
           <a:prstGeom prst="roundRect">
             <a:avLst>
@@ -5124,100 +5219,62 @@
           <a:bodyPr rtlCol="0" anchor="t" wrap="square" lIns="146304" rIns="146304" tIns="91440" bIns="91440"/>
           <a:lstStyle/>
           <a:p>
-            <a:pPr algn="ctr">
-              <a:spcAft>
-                <a:spcPts val="200"/>
-              </a:spcAft>
-            </a:pPr>
-            <a:r>
-              <a:rPr sz="1400" b="0">
+            <a:pPr algn="l">
+              <a:spcAft>
+                <a:spcPts val="300"/>
+              </a:spcAft>
+            </a:pPr>
+            <a:r>
+              <a:rPr sz="1200" b="1">
                 <a:solidFill>
                   <a:srgbClr val="211922"/>
                 </a:solidFill>
               </a:rPr>
-              <a:t>🏥</a:t>
-            </a:r>
-          </a:p>
-          <a:p>
-            <a:pPr algn="ctr">
-              <a:spcAft>
-                <a:spcPts val="200"/>
-              </a:spcAft>
-            </a:pPr>
-            <a:r>
-              <a:rPr sz="1100" b="1">
-                <a:solidFill>
-                  <a:srgbClr val="211922"/>
-                </a:solidFill>
-              </a:rPr>
-              <a:t>Referral</a:t>
-            </a:r>
-          </a:p>
-          <a:p>
-            <a:pPr algn="ctr">
-              <a:spcAft>
-                <a:spcPts val="200"/>
-              </a:spcAft>
-            </a:pPr>
-            <a:r>
-              <a:rPr sz="800" b="0">
+              <a:t>Kitchens cook menus, not plates.</a:t>
+            </a:r>
+          </a:p>
+          <a:p>
+            <a:pPr algn="l">
+              <a:spcAft>
+                <a:spcPts val="300"/>
+              </a:spcAft>
+            </a:pPr>
+            <a:r>
+              <a:rPr sz="1000" b="0">
                 <a:solidFill>
                   <a:srgbClr val="62625B"/>
                 </a:solidFill>
               </a:rPr>
-              <a:t>HL7-style discharge from the hospital</a:t>
-            </a:r>
-          </a:p>
-        </p:txBody>
-      </p:sp>
-      <p:sp>
-        <p:nvSpPr>
-          <p:cNvPr id="7" name="TextBox 6"/>
-          <p:cNvSpPr txBox="1"/>
-          <p:nvPr/>
-        </p:nvSpPr>
-        <p:spPr>
-          <a:xfrm>
-            <a:off x="2217420" y="2395728"/>
-            <a:ext cx="228600" cy="320040"/>
-          </a:xfrm>
-          <a:prstGeom prst="rect">
-            <a:avLst/>
-          </a:prstGeom>
-          <a:noFill/>
-        </p:spPr>
-        <p:txBody>
-          <a:bodyPr wrap="square" anchor="t" lIns="0" rIns="0" tIns="0" bIns="0">
-            <a:spAutoFit/>
-          </a:bodyPr>
-          <a:lstStyle/>
-          <a:p>
-            <a:pPr algn="ctr">
-              <a:spcAft>
-                <a:spcPts val="400"/>
-              </a:spcAft>
-            </a:pPr>
-            <a:r>
-              <a:rPr sz="1300" b="1">
-                <a:solidFill>
-                  <a:srgbClr val="62625B"/>
-                </a:solidFill>
-              </a:rPr>
-              <a:t>→</a:t>
-            </a:r>
-          </a:p>
-        </p:txBody>
-      </p:sp>
-      <p:sp>
-        <p:nvSpPr>
-          <p:cNvPr id="8" name="Rounded Rectangle 7"/>
+              <a:t>Bulk batches of a few recipes a day — never 150 bespoke meals.</a:t>
+            </a:r>
+          </a:p>
+          <a:p>
+            <a:pPr algn="l">
+              <a:spcAft>
+                <a:spcPts val="300"/>
+              </a:spcAft>
+            </a:pPr>
+            <a:r>
+              <a:rPr sz="900" b="1">
+                <a:solidFill>
+                  <a:srgbClr val="103C25"/>
+                </a:solidFill>
+              </a:rPr>
+              <a:t>→ 3–5 recipes/day menu planner</a:t>
+            </a:r>
+          </a:p>
+        </p:txBody>
+      </p:sp>
+      <p:sp>
+        <p:nvSpPr>
+          <p:cNvPr id="11" name="Rounded Rectangle 10"/>
           <p:cNvSpPr/>
           <p:nvPr/>
         </p:nvSpPr>
         <p:spPr>
           <a:xfrm>
-            <a:off x="2450591" y="1938528"/>
-            <a:ext cx="1700784" cy="1225296"/>
+            <a:off x="4334255" y="4956048"/>
+            <a:ext cx="3657600" cy="1298448"/>
           </a:xfrm>
           <a:prstGeom prst="roundRect">
             <a:avLst>
@@ -5252,100 +5309,62 @@
           <a:bodyPr rtlCol="0" anchor="t" wrap="square" lIns="146304" rIns="146304" tIns="91440" bIns="91440"/>
           <a:lstStyle/>
           <a:p>
-            <a:pPr algn="ctr">
-              <a:spcAft>
-                <a:spcPts val="200"/>
-              </a:spcAft>
-            </a:pPr>
-            <a:r>
-              <a:rPr sz="1400" b="0">
+            <a:pPr algn="l">
+              <a:spcAft>
+                <a:spcPts val="300"/>
+              </a:spcAft>
+            </a:pPr>
+            <a:r>
+              <a:rPr sz="1200" b="1">
                 <a:solidFill>
                   <a:srgbClr val="211922"/>
                 </a:solidFill>
               </a:rPr>
-              <a:t>📋</a:t>
-            </a:r>
-          </a:p>
-          <a:p>
-            <a:pPr algn="ctr">
-              <a:spcAft>
-                <a:spcPts val="200"/>
-              </a:spcAft>
-            </a:pPr>
-            <a:r>
-              <a:rPr sz="1100" b="1">
-                <a:solidFill>
-                  <a:srgbClr val="211922"/>
-                </a:solidFill>
-              </a:rPr>
-              <a:t>Intake Agent</a:t>
-            </a:r>
-          </a:p>
-          <a:p>
-            <a:pPr algn="ctr">
-              <a:spcAft>
-                <a:spcPts val="200"/>
-              </a:spcAft>
-            </a:pPr>
-            <a:r>
-              <a:rPr sz="800" b="0">
+              <a:t>Donations are a lottery.</a:t>
+            </a:r>
+          </a:p>
+          <a:p>
+            <a:pPr algn="l">
+              <a:spcAft>
+                <a:spcPts val="300"/>
+              </a:spcAft>
+            </a:pPr>
+            <a:r>
+              <a:rPr sz="1000" b="0">
                 <a:solidFill>
                   <a:srgbClr val="62625B"/>
                 </a:solidFill>
               </a:rPr>
-              <a:t>structures diets, allergies, hard limits</a:t>
-            </a:r>
-          </a:p>
-        </p:txBody>
-      </p:sp>
-      <p:sp>
-        <p:nvSpPr>
-          <p:cNvPr id="9" name="TextBox 8"/>
-          <p:cNvSpPr txBox="1"/>
-          <p:nvPr/>
-        </p:nvSpPr>
-        <p:spPr>
-          <a:xfrm>
-            <a:off x="4165091" y="2395728"/>
-            <a:ext cx="228600" cy="320040"/>
-          </a:xfrm>
-          <a:prstGeom prst="rect">
-            <a:avLst/>
-          </a:prstGeom>
-          <a:noFill/>
-        </p:spPr>
-        <p:txBody>
-          <a:bodyPr wrap="square" anchor="t" lIns="0" rIns="0" tIns="0" bIns="0">
-            <a:spAutoFit/>
-          </a:bodyPr>
-          <a:lstStyle/>
-          <a:p>
-            <a:pPr algn="ctr">
-              <a:spcAft>
-                <a:spcPts val="400"/>
-              </a:spcAft>
-            </a:pPr>
-            <a:r>
-              <a:rPr sz="1300" b="1">
-                <a:solidFill>
-                  <a:srgbClr val="62625B"/>
-                </a:solidFill>
-              </a:rPr>
-              <a:t>→</a:t>
-            </a:r>
-          </a:p>
-        </p:txBody>
-      </p:sp>
-      <p:sp>
-        <p:nvSpPr>
-          <p:cNvPr id="10" name="Rounded Rectangle 9"/>
+              <a:t>What arrives is unpredictable; using it well is the margin that funds meals.</a:t>
+            </a:r>
+          </a:p>
+          <a:p>
+            <a:pPr algn="l">
+              <a:spcAft>
+                <a:spcPts val="300"/>
+              </a:spcAft>
+            </a:pPr>
+            <a:r>
+              <a:rPr sz="900" b="1">
+                <a:solidFill>
+                  <a:srgbClr val="103C25"/>
+                </a:solidFill>
+              </a:rPr>
+              <a:t>→ triage gate + donation-to-recipe routing</a:t>
+            </a:r>
+          </a:p>
+        </p:txBody>
+      </p:sp>
+      <p:sp>
+        <p:nvSpPr>
+          <p:cNvPr id="12" name="Rounded Rectangle 11"/>
           <p:cNvSpPr/>
           <p:nvPr/>
         </p:nvSpPr>
         <p:spPr>
           <a:xfrm>
-            <a:off x="4398264" y="1938528"/>
-            <a:ext cx="1700784" cy="1225296"/>
+            <a:off x="8119871" y="4956048"/>
+            <a:ext cx="3657600" cy="1298448"/>
           </a:xfrm>
           <a:prstGeom prst="roundRect">
             <a:avLst>
@@ -5380,62 +5399,62 @@
           <a:bodyPr rtlCol="0" anchor="t" wrap="square" lIns="146304" rIns="146304" tIns="91440" bIns="91440"/>
           <a:lstStyle/>
           <a:p>
-            <a:pPr algn="ctr">
-              <a:spcAft>
-                <a:spcPts val="200"/>
-              </a:spcAft>
-            </a:pPr>
-            <a:r>
-              <a:rPr sz="1400" b="0">
+            <a:pPr algn="l">
+              <a:spcAft>
+                <a:spcPts val="300"/>
+              </a:spcAft>
+            </a:pPr>
+            <a:r>
+              <a:rPr sz="1200" b="1">
                 <a:solidFill>
                   <a:srgbClr val="211922"/>
                 </a:solidFill>
               </a:rPr>
-              <a:t>🩺</a:t>
-            </a:r>
-          </a:p>
-          <a:p>
-            <a:pPr algn="ctr">
-              <a:spcAft>
-                <a:spcPts val="200"/>
-              </a:spcAft>
-            </a:pPr>
-            <a:r>
-              <a:rPr sz="1100" b="1">
-                <a:solidFill>
-                  <a:srgbClr val="211922"/>
-                </a:solidFill>
-              </a:rPr>
-              <a:t>Clinical Matching</a:t>
-            </a:r>
-          </a:p>
-          <a:p>
-            <a:pPr algn="ctr">
-              <a:spcAft>
-                <a:spcPts val="200"/>
-              </a:spcAft>
-            </a:pPr>
-            <a:r>
-              <a:rPr sz="800" b="0">
+              <a:t>A human signs off on safety.</a:t>
+            </a:r>
+          </a:p>
+          <a:p>
+            <a:pPr algn="l">
+              <a:spcAft>
+                <a:spcPts val="300"/>
+              </a:spcAft>
+            </a:pPr>
+            <a:r>
+              <a:rPr sz="1000" b="0">
                 <a:solidFill>
                   <a:srgbClr val="62625B"/>
                 </a:solidFill>
               </a:rPr>
-              <a:t>hard checks exclude — never “score down”</a:t>
-            </a:r>
-          </a:p>
-        </p:txBody>
-      </p:sp>
-      <p:sp>
-        <p:nvSpPr>
-          <p:cNvPr id="11" name="TextBox 10"/>
+              <a:t>The nutrition team is clinically accountable — automation can draft, not decide.</a:t>
+            </a:r>
+          </a:p>
+          <a:p>
+            <a:pPr algn="l">
+              <a:spcAft>
+                <a:spcPts val="300"/>
+              </a:spcAft>
+            </a:pPr>
+            <a:r>
+              <a:rPr sz="900" b="1">
+                <a:solidFill>
+                  <a:srgbClr val="103C25"/>
+                </a:solidFill>
+              </a:rPr>
+              <a:t>→ approve-to-send workflow, gated on 0 issues</a:t>
+            </a:r>
+          </a:p>
+        </p:txBody>
+      </p:sp>
+      <p:sp>
+        <p:nvSpPr>
+          <p:cNvPr id="13" name="TextBox 12"/>
           <p:cNvSpPr txBox="1"/>
           <p:nvPr/>
         </p:nvSpPr>
         <p:spPr>
           <a:xfrm>
-            <a:off x="6112764" y="2395728"/>
-            <a:ext cx="228600" cy="320040"/>
+            <a:off x="548640" y="6419088"/>
+            <a:ext cx="8686800" cy="320040"/>
           </a:xfrm>
           <a:prstGeom prst="rect">
             <a:avLst/>
@@ -5448,31 +5467,273 @@
           </a:bodyPr>
           <a:lstStyle/>
           <a:p>
-            <a:pPr algn="ctr">
+            <a:pPr algn="l">
               <a:spcAft>
                 <a:spcPts val="400"/>
               </a:spcAft>
             </a:pPr>
             <a:r>
-              <a:rPr sz="1300" b="1">
+              <a:rPr sz="900" b="0">
                 <a:solidFill>
                   <a:srgbClr val="62625B"/>
                 </a:solidFill>
               </a:rPr>
-              <a:t>→</a:t>
-            </a:r>
-          </a:p>
-        </p:txBody>
-      </p:sp>
-      <p:sp>
-        <p:nvSpPr>
-          <p:cNvPr id="12" name="Rounded Rectangle 11"/>
+              <a:t>What we learned became the product's shape</a:t>
+            </a:r>
+          </a:p>
+        </p:txBody>
+      </p:sp>
+      <p:sp>
+        <p:nvSpPr>
+          <p:cNvPr id="14" name="TextBox 13"/>
+          <p:cNvSpPr txBox="1"/>
+          <p:nvPr/>
+        </p:nvSpPr>
+        <p:spPr>
+          <a:xfrm>
+            <a:off x="10972800" y="6419088"/>
+            <a:ext cx="731520" cy="320040"/>
+          </a:xfrm>
+          <a:prstGeom prst="rect">
+            <a:avLst/>
+          </a:prstGeom>
+          <a:noFill/>
+        </p:spPr>
+        <p:txBody>
+          <a:bodyPr wrap="square" anchor="t" lIns="0" rIns="0" tIns="0" bIns="0">
+            <a:spAutoFit/>
+          </a:bodyPr>
+          <a:lstStyle/>
+          <a:p>
+            <a:pPr algn="r">
+              <a:spcAft>
+                <a:spcPts val="400"/>
+              </a:spcAft>
+            </a:pPr>
+            <a:r>
+              <a:rPr sz="900" b="0">
+                <a:solidFill>
+                  <a:srgbClr val="62625B"/>
+                </a:solidFill>
+              </a:rPr>
+              <a:t>3 / 4</a:t>
+            </a:r>
+          </a:p>
+        </p:txBody>
+      </p:sp>
+    </p:spTree>
+  </p:cSld>
+  <p:clrMapOvr>
+    <a:masterClrMapping/>
+  </p:clrMapOvr>
+</p:sld>
+</file>
+
+<file path=ppt/slides/slide4.xml><?xml version="1.0" encoding="utf-8"?>
+<p:sld xmlns:a="http://schemas.openxmlformats.org/drawingml/2006/main" xmlns:p="http://schemas.openxmlformats.org/presentationml/2006/main" xmlns:r="http://schemas.openxmlformats.org/officeDocument/2006/relationships">
+  <p:cSld>
+    <p:bg>
+      <p:bgPr>
+        <a:solidFill>
+          <a:srgbClr val="FBFBF9"/>
+        </a:solidFill>
+        <a:effectLst/>
+      </p:bgPr>
+    </p:bg>
+    <p:spTree>
+      <p:nvGrpSpPr>
+        <p:cNvPr id="1" name=""/>
+        <p:cNvGrpSpPr/>
+        <p:nvPr/>
+      </p:nvGrpSpPr>
+      <p:grpSpPr/>
+      <p:sp>
+        <p:nvSpPr>
+          <p:cNvPr id="2" name="Oval 1"/>
           <p:cNvSpPr/>
           <p:nvPr/>
         </p:nvSpPr>
         <p:spPr>
           <a:xfrm>
-            <a:off x="6345936" y="1938528"/>
+            <a:off x="502920" y="384048"/>
+            <a:ext cx="384048" cy="384048"/>
+          </a:xfrm>
+          <a:prstGeom prst="ellipse">
+            <a:avLst/>
+          </a:prstGeom>
+          <a:solidFill>
+            <a:srgbClr val="E60023"/>
+          </a:solidFill>
+          <a:ln>
+            <a:noFill/>
+          </a:ln>
+          <a:effectLst/>
+        </p:spPr>
+        <p:style>
+          <a:lnRef idx="1">
+            <a:schemeClr val="accent1"/>
+          </a:lnRef>
+          <a:fillRef idx="3">
+            <a:schemeClr val="accent1"/>
+          </a:fillRef>
+          <a:effectRef idx="2">
+            <a:schemeClr val="accent1"/>
+          </a:effectRef>
+          <a:fontRef idx="minor">
+            <a:schemeClr val="lt1"/>
+          </a:fontRef>
+        </p:style>
+        <p:txBody>
+          <a:bodyPr rtlCol="0" anchor="ctr" wrap="square" lIns="146304" rIns="146304" tIns="91440" bIns="91440"/>
+          <a:lstStyle/>
+          <a:p>
+            <a:pPr algn="ctr">
+              <a:spcAft>
+                <a:spcPts val="300"/>
+              </a:spcAft>
+            </a:pPr>
+            <a:r>
+              <a:rPr sz="1400" b="1">
+                <a:solidFill>
+                  <a:srgbClr val="FFFFFF"/>
+                </a:solidFill>
+              </a:rPr>
+              <a:t>♥</a:t>
+            </a:r>
+          </a:p>
+        </p:txBody>
+      </p:sp>
+      <p:sp>
+        <p:nvSpPr>
+          <p:cNvPr id="3" name="TextBox 2"/>
+          <p:cNvSpPr txBox="1"/>
+          <p:nvPr/>
+        </p:nvSpPr>
+        <p:spPr>
+          <a:xfrm>
+            <a:off x="1024128" y="384048"/>
+            <a:ext cx="9601200" cy="411480"/>
+          </a:xfrm>
+          <a:prstGeom prst="rect">
+            <a:avLst/>
+          </a:prstGeom>
+          <a:noFill/>
+        </p:spPr>
+        <p:txBody>
+          <a:bodyPr wrap="square" anchor="ctr" lIns="0" rIns="0" tIns="0" bIns="0">
+            <a:spAutoFit/>
+          </a:bodyPr>
+          <a:lstStyle/>
+          <a:p>
+            <a:pPr algn="l">
+              <a:spcAft>
+                <a:spcPts val="400"/>
+              </a:spcAft>
+            </a:pPr>
+            <a:r>
+              <a:rPr sz="1500" b="1">
+                <a:solidFill>
+                  <a:srgbClr val="211922"/>
+                </a:solidFill>
+              </a:rPr>
+              <a:t>RxKitchen</a:t>
+            </a:r>
+            <a:r>
+              <a:rPr sz="1100" b="0">
+                <a:solidFill>
+                  <a:srgbClr val="62625B"/>
+                </a:solidFill>
+              </a:rPr>
+              <a:t>   · how it works</a:t>
+            </a:r>
+          </a:p>
+        </p:txBody>
+      </p:sp>
+      <p:sp>
+        <p:nvSpPr>
+          <p:cNvPr id="4" name="TextBox 3"/>
+          <p:cNvSpPr txBox="1"/>
+          <p:nvPr/>
+        </p:nvSpPr>
+        <p:spPr>
+          <a:xfrm>
+            <a:off x="548640" y="1005840"/>
+            <a:ext cx="7315200" cy="320040"/>
+          </a:xfrm>
+          <a:prstGeom prst="rect">
+            <a:avLst/>
+          </a:prstGeom>
+          <a:noFill/>
+        </p:spPr>
+        <p:txBody>
+          <a:bodyPr wrap="square" anchor="t" lIns="0" rIns="0" tIns="0" bIns="0">
+            <a:spAutoFit/>
+          </a:bodyPr>
+          <a:lstStyle/>
+          <a:p>
+            <a:pPr algn="l">
+              <a:spcAft>
+                <a:spcPts val="400"/>
+              </a:spcAft>
+            </a:pPr>
+            <a:r>
+              <a:rPr sz="1200" b="1">
+                <a:solidFill>
+                  <a:srgbClr val="E60023"/>
+                </a:solidFill>
+              </a:rPr>
+              <a:t>REFERRAL TO DOORSTEP, IN MINUTES</a:t>
+            </a:r>
+          </a:p>
+        </p:txBody>
+      </p:sp>
+      <p:sp>
+        <p:nvSpPr>
+          <p:cNvPr id="5" name="TextBox 4"/>
+          <p:cNvSpPr txBox="1"/>
+          <p:nvPr/>
+        </p:nvSpPr>
+        <p:spPr>
+          <a:xfrm>
+            <a:off x="548640" y="1298448"/>
+            <a:ext cx="11155680" cy="502920"/>
+          </a:xfrm>
+          <a:prstGeom prst="rect">
+            <a:avLst/>
+          </a:prstGeom>
+          <a:noFill/>
+        </p:spPr>
+        <p:txBody>
+          <a:bodyPr wrap="square" anchor="t" lIns="0" rIns="0" tIns="0" bIns="0">
+            <a:spAutoFit/>
+          </a:bodyPr>
+          <a:lstStyle/>
+          <a:p>
+            <a:pPr algn="l">
+              <a:spcAft>
+                <a:spcPts val="400"/>
+              </a:spcAft>
+            </a:pPr>
+            <a:r>
+              <a:rPr sz="2600" b="1">
+                <a:solidFill>
+                  <a:srgbClr val="211922"/>
+                </a:solidFill>
+              </a:rPr>
+              <a:t>Specialist agents, one safety hierarchy, a human decision</a:t>
+            </a:r>
+          </a:p>
+        </p:txBody>
+      </p:sp>
+      <p:sp>
+        <p:nvSpPr>
+          <p:cNvPr id="6" name="Rounded Rectangle 5"/>
+          <p:cNvSpPr/>
+          <p:nvPr/>
+        </p:nvSpPr>
+        <p:spPr>
+          <a:xfrm>
+            <a:off x="502920" y="1938528"/>
             <a:ext cx="1700784" cy="1225296"/>
           </a:xfrm>
           <a:prstGeom prst="roundRect">
@@ -5519,7 +5780,7 @@
                   <a:srgbClr val="211922"/>
                 </a:solidFill>
               </a:rPr>
-              <a:t>🍳</a:t>
+              <a:t>🏥</a:t>
             </a:r>
           </a:p>
           <a:p>
@@ -5534,7 +5795,7 @@
                   <a:srgbClr val="211922"/>
                 </a:solidFill>
               </a:rPr>
-              <a:t>Kitchen Planning</a:t>
+              <a:t>Referral</a:t>
             </a:r>
           </a:p>
           <a:p>
@@ -5549,20 +5810,20 @@
                   <a:srgbClr val="62625B"/>
                 </a:solidFill>
               </a:rPr>
-              <a:t>daily menus + fresh batches from real demand</a:t>
-            </a:r>
-          </a:p>
-        </p:txBody>
-      </p:sp>
-      <p:sp>
-        <p:nvSpPr>
-          <p:cNvPr id="13" name="TextBox 12"/>
+              <a:t>HL7-style discharge from the hospital</a:t>
+            </a:r>
+          </a:p>
+        </p:txBody>
+      </p:sp>
+      <p:sp>
+        <p:nvSpPr>
+          <p:cNvPr id="7" name="TextBox 6"/>
           <p:cNvSpPr txBox="1"/>
           <p:nvPr/>
         </p:nvSpPr>
         <p:spPr>
           <a:xfrm>
-            <a:off x="8060436" y="2395728"/>
+            <a:off x="2217420" y="2395728"/>
             <a:ext cx="228600" cy="320040"/>
           </a:xfrm>
           <a:prstGeom prst="rect">
@@ -5594,13 +5855,13 @@
       </p:sp>
       <p:sp>
         <p:nvSpPr>
-          <p:cNvPr id="14" name="Rounded Rectangle 13"/>
+          <p:cNvPr id="8" name="Rounded Rectangle 7"/>
           <p:cNvSpPr/>
           <p:nvPr/>
         </p:nvSpPr>
         <p:spPr>
           <a:xfrm>
-            <a:off x="8293608" y="1938528"/>
+            <a:off x="2450591" y="1938528"/>
             <a:ext cx="1700784" cy="1225296"/>
           </a:xfrm>
           <a:prstGeom prst="roundRect">
@@ -5647,7 +5908,7 @@
                   <a:srgbClr val="211922"/>
                 </a:solidFill>
               </a:rPr>
-              <a:t>📦</a:t>
+              <a:t>📋</a:t>
             </a:r>
           </a:p>
           <a:p>
@@ -5662,7 +5923,7 @@
                   <a:srgbClr val="211922"/>
                 </a:solidFill>
               </a:rPr>
-              <a:t>Donation Triage</a:t>
+              <a:t>Intake Agent</a:t>
             </a:r>
           </a:p>
           <a:p>
@@ -5677,20 +5938,20 @@
                   <a:srgbClr val="62625B"/>
                 </a:solidFill>
               </a:rPr>
-              <a:t>food-safety gate routes arrivals to recipes</a:t>
-            </a:r>
-          </a:p>
-        </p:txBody>
-      </p:sp>
-      <p:sp>
-        <p:nvSpPr>
-          <p:cNvPr id="15" name="TextBox 14"/>
+              <a:t>structures diets, allergies, hard limits</a:t>
+            </a:r>
+          </a:p>
+        </p:txBody>
+      </p:sp>
+      <p:sp>
+        <p:nvSpPr>
+          <p:cNvPr id="9" name="TextBox 8"/>
           <p:cNvSpPr txBox="1"/>
           <p:nvPr/>
         </p:nvSpPr>
         <p:spPr>
           <a:xfrm>
-            <a:off x="10008108" y="2395728"/>
+            <a:off x="4165091" y="2395728"/>
             <a:ext cx="228600" cy="320040"/>
           </a:xfrm>
           <a:prstGeom prst="rect">
@@ -5722,13 +5983,13 @@
       </p:sp>
       <p:sp>
         <p:nvSpPr>
-          <p:cNvPr id="16" name="Rounded Rectangle 15"/>
+          <p:cNvPr id="10" name="Rounded Rectangle 9"/>
           <p:cNvSpPr/>
           <p:nvPr/>
         </p:nvSpPr>
         <p:spPr>
           <a:xfrm>
-            <a:off x="10241280" y="1938528"/>
+            <a:off x="4398264" y="1938528"/>
             <a:ext cx="1700784" cy="1225296"/>
           </a:xfrm>
           <a:prstGeom prst="roundRect">
@@ -5775,7 +6036,7 @@
                   <a:srgbClr val="211922"/>
                 </a:solidFill>
               </a:rPr>
-              <a:t>✅</a:t>
+              <a:t>🩺</a:t>
             </a:r>
           </a:p>
           <a:p>
@@ -5790,7 +6051,7 @@
                   <a:srgbClr val="211922"/>
                 </a:solidFill>
               </a:rPr>
-              <a:t>CNO approves</a:t>
+              <a:t>Clinical Matching</a:t>
             </a:r>
           </a:p>
           <a:p>
@@ -5805,21 +6066,59 @@
                   <a:srgbClr val="62625B"/>
                 </a:solidFill>
               </a:rPr>
-              <a:t>gated on zero issues → cook sheet to kitchen</a:t>
-            </a:r>
-          </a:p>
-        </p:txBody>
-      </p:sp>
-      <p:sp>
-        <p:nvSpPr>
-          <p:cNvPr id="17" name="Rounded Rectangle 16"/>
+              <a:t>hard checks exclude — never “score down”</a:t>
+            </a:r>
+          </a:p>
+        </p:txBody>
+      </p:sp>
+      <p:sp>
+        <p:nvSpPr>
+          <p:cNvPr id="11" name="TextBox 10"/>
+          <p:cNvSpPr txBox="1"/>
+          <p:nvPr/>
+        </p:nvSpPr>
+        <p:spPr>
+          <a:xfrm>
+            <a:off x="6112764" y="2395728"/>
+            <a:ext cx="228600" cy="320040"/>
+          </a:xfrm>
+          <a:prstGeom prst="rect">
+            <a:avLst/>
+          </a:prstGeom>
+          <a:noFill/>
+        </p:spPr>
+        <p:txBody>
+          <a:bodyPr wrap="square" anchor="t" lIns="0" rIns="0" tIns="0" bIns="0">
+            <a:spAutoFit/>
+          </a:bodyPr>
+          <a:lstStyle/>
+          <a:p>
+            <a:pPr algn="ctr">
+              <a:spcAft>
+                <a:spcPts val="400"/>
+              </a:spcAft>
+            </a:pPr>
+            <a:r>
+              <a:rPr sz="1300" b="1">
+                <a:solidFill>
+                  <a:srgbClr val="62625B"/>
+                </a:solidFill>
+              </a:rPr>
+              <a:t>→</a:t>
+            </a:r>
+          </a:p>
+        </p:txBody>
+      </p:sp>
+      <p:sp>
+        <p:nvSpPr>
+          <p:cNvPr id="12" name="Rounded Rectangle 11"/>
           <p:cNvSpPr/>
           <p:nvPr/>
         </p:nvSpPr>
         <p:spPr>
           <a:xfrm>
-            <a:off x="548640" y="3401568"/>
-            <a:ext cx="5989320" cy="2697480"/>
+            <a:off x="6345936" y="1938528"/>
+            <a:ext cx="1700784" cy="1225296"/>
           </a:xfrm>
           <a:prstGeom prst="roundRect">
             <a:avLst>
@@ -5854,6 +6153,352 @@
           <a:bodyPr rtlCol="0" anchor="t" wrap="square" lIns="146304" rIns="146304" tIns="91440" bIns="91440"/>
           <a:lstStyle/>
           <a:p>
+            <a:pPr algn="ctr">
+              <a:spcAft>
+                <a:spcPts val="200"/>
+              </a:spcAft>
+            </a:pPr>
+            <a:r>
+              <a:rPr sz="1400" b="0">
+                <a:solidFill>
+                  <a:srgbClr val="211922"/>
+                </a:solidFill>
+              </a:rPr>
+              <a:t>🍳</a:t>
+            </a:r>
+          </a:p>
+          <a:p>
+            <a:pPr algn="ctr">
+              <a:spcAft>
+                <a:spcPts val="200"/>
+              </a:spcAft>
+            </a:pPr>
+            <a:r>
+              <a:rPr sz="1100" b="1">
+                <a:solidFill>
+                  <a:srgbClr val="211922"/>
+                </a:solidFill>
+              </a:rPr>
+              <a:t>Kitchen Planning</a:t>
+            </a:r>
+          </a:p>
+          <a:p>
+            <a:pPr algn="ctr">
+              <a:spcAft>
+                <a:spcPts val="200"/>
+              </a:spcAft>
+            </a:pPr>
+            <a:r>
+              <a:rPr sz="800" b="0">
+                <a:solidFill>
+                  <a:srgbClr val="62625B"/>
+                </a:solidFill>
+              </a:rPr>
+              <a:t>daily menus + fresh batches from real demand</a:t>
+            </a:r>
+          </a:p>
+        </p:txBody>
+      </p:sp>
+      <p:sp>
+        <p:nvSpPr>
+          <p:cNvPr id="13" name="TextBox 12"/>
+          <p:cNvSpPr txBox="1"/>
+          <p:nvPr/>
+        </p:nvSpPr>
+        <p:spPr>
+          <a:xfrm>
+            <a:off x="8060436" y="2395728"/>
+            <a:ext cx="228600" cy="320040"/>
+          </a:xfrm>
+          <a:prstGeom prst="rect">
+            <a:avLst/>
+          </a:prstGeom>
+          <a:noFill/>
+        </p:spPr>
+        <p:txBody>
+          <a:bodyPr wrap="square" anchor="t" lIns="0" rIns="0" tIns="0" bIns="0">
+            <a:spAutoFit/>
+          </a:bodyPr>
+          <a:lstStyle/>
+          <a:p>
+            <a:pPr algn="ctr">
+              <a:spcAft>
+                <a:spcPts val="400"/>
+              </a:spcAft>
+            </a:pPr>
+            <a:r>
+              <a:rPr sz="1300" b="1">
+                <a:solidFill>
+                  <a:srgbClr val="62625B"/>
+                </a:solidFill>
+              </a:rPr>
+              <a:t>→</a:t>
+            </a:r>
+          </a:p>
+        </p:txBody>
+      </p:sp>
+      <p:sp>
+        <p:nvSpPr>
+          <p:cNvPr id="14" name="Rounded Rectangle 13"/>
+          <p:cNvSpPr/>
+          <p:nvPr/>
+        </p:nvSpPr>
+        <p:spPr>
+          <a:xfrm>
+            <a:off x="8293608" y="1938528"/>
+            <a:ext cx="1700784" cy="1225296"/>
+          </a:xfrm>
+          <a:prstGeom prst="roundRect">
+            <a:avLst>
+              <a:gd name="adj" fmla="val 10000"/>
+            </a:avLst>
+          </a:prstGeom>
+          <a:solidFill>
+            <a:srgbClr val="FFFFFF"/>
+          </a:solidFill>
+          <a:ln w="12700">
+            <a:solidFill>
+              <a:srgbClr val="DADAD3"/>
+            </a:solidFill>
+          </a:ln>
+          <a:effectLst/>
+        </p:spPr>
+        <p:style>
+          <a:lnRef idx="1">
+            <a:schemeClr val="accent1"/>
+          </a:lnRef>
+          <a:fillRef idx="3">
+            <a:schemeClr val="accent1"/>
+          </a:fillRef>
+          <a:effectRef idx="2">
+            <a:schemeClr val="accent1"/>
+          </a:effectRef>
+          <a:fontRef idx="minor">
+            <a:schemeClr val="lt1"/>
+          </a:fontRef>
+        </p:style>
+        <p:txBody>
+          <a:bodyPr rtlCol="0" anchor="t" wrap="square" lIns="146304" rIns="146304" tIns="91440" bIns="91440"/>
+          <a:lstStyle/>
+          <a:p>
+            <a:pPr algn="ctr">
+              <a:spcAft>
+                <a:spcPts val="200"/>
+              </a:spcAft>
+            </a:pPr>
+            <a:r>
+              <a:rPr sz="1400" b="0">
+                <a:solidFill>
+                  <a:srgbClr val="211922"/>
+                </a:solidFill>
+              </a:rPr>
+              <a:t>📦</a:t>
+            </a:r>
+          </a:p>
+          <a:p>
+            <a:pPr algn="ctr">
+              <a:spcAft>
+                <a:spcPts val="200"/>
+              </a:spcAft>
+            </a:pPr>
+            <a:r>
+              <a:rPr sz="1100" b="1">
+                <a:solidFill>
+                  <a:srgbClr val="211922"/>
+                </a:solidFill>
+              </a:rPr>
+              <a:t>Donation Triage</a:t>
+            </a:r>
+          </a:p>
+          <a:p>
+            <a:pPr algn="ctr">
+              <a:spcAft>
+                <a:spcPts val="200"/>
+              </a:spcAft>
+            </a:pPr>
+            <a:r>
+              <a:rPr sz="800" b="0">
+                <a:solidFill>
+                  <a:srgbClr val="62625B"/>
+                </a:solidFill>
+              </a:rPr>
+              <a:t>food-safety gate routes arrivals to recipes</a:t>
+            </a:r>
+          </a:p>
+        </p:txBody>
+      </p:sp>
+      <p:sp>
+        <p:nvSpPr>
+          <p:cNvPr id="15" name="TextBox 14"/>
+          <p:cNvSpPr txBox="1"/>
+          <p:nvPr/>
+        </p:nvSpPr>
+        <p:spPr>
+          <a:xfrm>
+            <a:off x="10008108" y="2395728"/>
+            <a:ext cx="228600" cy="320040"/>
+          </a:xfrm>
+          <a:prstGeom prst="rect">
+            <a:avLst/>
+          </a:prstGeom>
+          <a:noFill/>
+        </p:spPr>
+        <p:txBody>
+          <a:bodyPr wrap="square" anchor="t" lIns="0" rIns="0" tIns="0" bIns="0">
+            <a:spAutoFit/>
+          </a:bodyPr>
+          <a:lstStyle/>
+          <a:p>
+            <a:pPr algn="ctr">
+              <a:spcAft>
+                <a:spcPts val="400"/>
+              </a:spcAft>
+            </a:pPr>
+            <a:r>
+              <a:rPr sz="1300" b="1">
+                <a:solidFill>
+                  <a:srgbClr val="62625B"/>
+                </a:solidFill>
+              </a:rPr>
+              <a:t>→</a:t>
+            </a:r>
+          </a:p>
+        </p:txBody>
+      </p:sp>
+      <p:sp>
+        <p:nvSpPr>
+          <p:cNvPr id="16" name="Rounded Rectangle 15"/>
+          <p:cNvSpPr/>
+          <p:nvPr/>
+        </p:nvSpPr>
+        <p:spPr>
+          <a:xfrm>
+            <a:off x="10241280" y="1938528"/>
+            <a:ext cx="1700784" cy="1225296"/>
+          </a:xfrm>
+          <a:prstGeom prst="roundRect">
+            <a:avLst>
+              <a:gd name="adj" fmla="val 10000"/>
+            </a:avLst>
+          </a:prstGeom>
+          <a:solidFill>
+            <a:srgbClr val="FFFFFF"/>
+          </a:solidFill>
+          <a:ln w="12700">
+            <a:solidFill>
+              <a:srgbClr val="DADAD3"/>
+            </a:solidFill>
+          </a:ln>
+          <a:effectLst/>
+        </p:spPr>
+        <p:style>
+          <a:lnRef idx="1">
+            <a:schemeClr val="accent1"/>
+          </a:lnRef>
+          <a:fillRef idx="3">
+            <a:schemeClr val="accent1"/>
+          </a:fillRef>
+          <a:effectRef idx="2">
+            <a:schemeClr val="accent1"/>
+          </a:effectRef>
+          <a:fontRef idx="minor">
+            <a:schemeClr val="lt1"/>
+          </a:fontRef>
+        </p:style>
+        <p:txBody>
+          <a:bodyPr rtlCol="0" anchor="t" wrap="square" lIns="146304" rIns="146304" tIns="91440" bIns="91440"/>
+          <a:lstStyle/>
+          <a:p>
+            <a:pPr algn="ctr">
+              <a:spcAft>
+                <a:spcPts val="200"/>
+              </a:spcAft>
+            </a:pPr>
+            <a:r>
+              <a:rPr sz="1400" b="0">
+                <a:solidFill>
+                  <a:srgbClr val="211922"/>
+                </a:solidFill>
+              </a:rPr>
+              <a:t>✅</a:t>
+            </a:r>
+          </a:p>
+          <a:p>
+            <a:pPr algn="ctr">
+              <a:spcAft>
+                <a:spcPts val="200"/>
+              </a:spcAft>
+            </a:pPr>
+            <a:r>
+              <a:rPr sz="1100" b="1">
+                <a:solidFill>
+                  <a:srgbClr val="211922"/>
+                </a:solidFill>
+              </a:rPr>
+              <a:t>CNO approves</a:t>
+            </a:r>
+          </a:p>
+          <a:p>
+            <a:pPr algn="ctr">
+              <a:spcAft>
+                <a:spcPts val="200"/>
+              </a:spcAft>
+            </a:pPr>
+            <a:r>
+              <a:rPr sz="800" b="0">
+                <a:solidFill>
+                  <a:srgbClr val="62625B"/>
+                </a:solidFill>
+              </a:rPr>
+              <a:t>gated on zero issues → cook sheet to kitchen</a:t>
+            </a:r>
+          </a:p>
+        </p:txBody>
+      </p:sp>
+      <p:sp>
+        <p:nvSpPr>
+          <p:cNvPr id="17" name="Rounded Rectangle 16"/>
+          <p:cNvSpPr/>
+          <p:nvPr/>
+        </p:nvSpPr>
+        <p:spPr>
+          <a:xfrm>
+            <a:off x="548640" y="3401568"/>
+            <a:ext cx="5989320" cy="2697480"/>
+          </a:xfrm>
+          <a:prstGeom prst="roundRect">
+            <a:avLst>
+              <a:gd name="adj" fmla="val 10000"/>
+            </a:avLst>
+          </a:prstGeom>
+          <a:solidFill>
+            <a:srgbClr val="FFFFFF"/>
+          </a:solidFill>
+          <a:ln w="12700">
+            <a:solidFill>
+              <a:srgbClr val="DADAD3"/>
+            </a:solidFill>
+          </a:ln>
+          <a:effectLst/>
+        </p:spPr>
+        <p:style>
+          <a:lnRef idx="1">
+            <a:schemeClr val="accent1"/>
+          </a:lnRef>
+          <a:fillRef idx="3">
+            <a:schemeClr val="accent1"/>
+          </a:fillRef>
+          <a:effectRef idx="2">
+            <a:schemeClr val="accent1"/>
+          </a:effectRef>
+          <a:fontRef idx="minor">
+            <a:schemeClr val="lt1"/>
+          </a:fontRef>
+        </p:style>
+        <p:txBody>
+          <a:bodyPr rtlCol="0" anchor="t" wrap="square" lIns="146304" rIns="146304" tIns="91440" bIns="91440"/>
+          <a:lstStyle/>
+          <a:p>
             <a:pPr algn="l">
               <a:spcAft>
                 <a:spcPts val="700"/>
@@ -6230,7 +6875,7 @@
                   <a:srgbClr val="62625B"/>
                 </a:solidFill>
               </a:rPr>
-              <a:t>3 / 3</a:t>
+              <a:t>4 / 4</a:t>
             </a:r>
           </a:p>
         </p:txBody>

</xml_diff>

<commit_message>
Pickup, not delivery — POH clients pick up their meals
Project Open Hand clients come to pick up meals; delivery framing was
wrong. Swept everywhere user-visible:

- Presentation (web + pptx): "referral to pickup", "prepares medically
  tailored meals that clients pick up", "nothing unsafe leaves the
  kitchen" (was "ships")
- App: "Pickup Coordinator" agent label (was Delivery Agent), hold
  button "Resume her meals", help guide "Nothing goes out without you",
  layout description
- Data narrative regenerated: agent events now read "Scheduling pickup"
  / "Meals ready for pickup <date>, window <time> (<zone> group)";
  scenario retitled "Referral to pickup: Client 1042"; Claude-pipeline
  prompts updated so future authored runs stay pickup-framed

Verified with a text scan across all four presentation slides: zero
delivery/doorstep/ships words; dataset revalidated (0 violations);
tsc + lint + build pass.

Co-Authored-By: Claude Fable 5 <noreply@anthropic.com>
</commit_message>
<xml_diff>
--- a/pitch/RxKitchen-pitch.pptx
+++ b/pitch/RxKitchen-pitch.pptx
@@ -3387,7 +3387,7 @@
                   <a:srgbClr val="211922"/>
                 </a:solidFill>
               </a:rPr>
-              <a:t>Agents propose. She decides. Nothing unsafe ships.</a:t>
+              <a:t>Agents propose. She decides. Nothing unsafe leaves the kitchen.</a:t>
             </a:r>
           </a:p>
         </p:txBody>
@@ -3537,7 +3537,7 @@
                   <a:srgbClr val="62625B"/>
                 </a:solidFill>
               </a:rPr>
-              <a:t>clients planned, referral to doorstep</a:t>
+              <a:t>clients planned, referral to pickup</a:t>
             </a:r>
           </a:p>
         </p:txBody>
@@ -4148,7 +4148,7 @@
                   <a:srgbClr val="62625B"/>
                 </a:solidFill>
               </a:rPr>
-              <a:t> (San Francisco) delivers medically tailored meals to clients discharged with diabetes, cardiovascular and renal conditions, and allergies.</a:t>
+              <a:t> (San Francisco) prepares medically tailored meals that clients pick up — prescribed for diabetes, cardiovascular and renal conditions, and allergies.</a:t>
             </a:r>
           </a:p>
           <a:p>
@@ -4346,7 +4346,7 @@
                   <a:srgbClr val="103C25"/>
                 </a:solidFill>
               </a:rPr>
-              <a:t>• Clinically accountable — she signs off on every meal that ships.</a:t>
+              <a:t>• Clinically accountable — she signs off on every meal that leaves the kitchen.</a:t>
             </a:r>
           </a:p>
           <a:p>
@@ -4391,7 +4391,7 @@
                   <a:srgbClr val="103C25"/>
                 </a:solidFill>
               </a:rPr>
-              <a:t>• Success = nothing unsafe ships, nobody unfed, donations not wasted.</a:t>
+              <a:t>• Success = nothing unsafe leaves the kitchen, nobody unfed, donations not wasted.</a:t>
             </a:r>
           </a:p>
           <a:p>
@@ -5682,7 +5682,7 @@
                   <a:srgbClr val="E60023"/>
                 </a:solidFill>
               </a:rPr>
-              <a:t>REFERRAL TO DOORSTEP, IN MINUTES</a:t>
+              <a:t>REFERRAL TO PICKUP, IN MINUTES</a:t>
             </a:r>
           </a:p>
         </p:txBody>

</xml_diff>